<commit_message>
Run of show; title and Cast AI citation fixes
</commit_message>
<xml_diff>
--- a/deck/kubecon-na-2026-v6.pptx
+++ b/deck/kubecon-na-2026-v6.pptx
@@ -898,7 +898,7 @@
           </a:p>
           <a:p>
             <a:r>
-              <a:t>"Across the industry the average production GPU runs at about 5% utilisation. Ours read 95%. Same counter. One looks saturated, one looks idle, and neither tells you anything about the inference work."</a:t>
+              <a:t>"Cast AI looked at tens of thousands of production Kubernetes clusters this year: the average GPU runs at 5% utilisation. Ours read 95%. Same counter. One looks saturated, one looks idle, and neither tells you anything about the inference work."</a:t>
             </a:r>
           </a:p>
           <a:p>
@@ -2139,7 +2139,7 @@
           </a:p>
           <a:p>
             <a:r>
-              <a:t>Danilo: "I'm Danilo, I build platforms for customers at AWS, mostly Kubernetes and ML infrastructure." Henrique: "I'm Henrique, AWS Support, I see a lot of GPU incidents after the fact." Point at the two chips: "We tried to explain a slow inference service with the GPU dashboard and got nothing. The answer was in a log line."</a:t>
+              <a:t>Danilo: "I'm Danilo, I build platforms for customers at AWS, mostly Kubernetes and ML infrastructure." Henrique: "I'm Henrique, Principal Cloud Engineer in AWS Support, I see a lot of GPU incidents after the fact." Point at the two chips: "We tried to explain a slow inference service with the GPU dashboard and got nothing. The answer was in a log line."</a:t>
             </a:r>
           </a:p>
           <a:p>
@@ -12836,7 +12836,7 @@
                 <a:cs typeface="Arial"/>
                 <a:sym typeface="Arial"/>
               </a:rPr>
-              <a:t>Henrique Santana, AWS Support</a:t>
+              <a:t>Henrique Santana, Principal Cloud Engineer, AWS</a:t>
             </a:r>
             <a:endParaRPr b="0" i="0" sz="1400" u="none" cap="none" strike="noStrike">
               <a:solidFill>
@@ -16973,7 +16973,7 @@
                 </a:solidFill>
                 <a:latin typeface="Arial"/>
               </a:rPr>
-              <a:t>Industry average production GPU utilisation ~5%: Cast AI, State of GPU utilisation 2026 (cast.ai/blog/fractional-gpu-kubernetes)</a:t>
+              <a:t>Average GPU utilisation across tens of thousands of production Kubernetes clusters: 5%. Cast AI, 2026 State of Kubernetes Optimization Report (cast.ai/blog/fractional-gpu-kubernetes)</a:t>
             </a:r>
           </a:p>
         </p:txBody>
@@ -17157,7 +17157,7 @@
                 </a:solidFill>
                 <a:latin typeface="Arial"/>
               </a:rPr>
-              <a:t>industry average</a:t>
+              <a:t>average prod K8s GPU</a:t>
             </a:r>
           </a:p>
           <a:p>

</xml_diff>